<commit_message>
feat: add purchasing info & FIRDI course slides, sync index.html and PPTX
</commit_message>
<xml_diff>
--- a/EM菌與光合菌農場實務手冊.pptx
+++ b/EM菌與光合菌農場實務手冊.pptx
@@ -38,6 +38,12 @@
     <p:sldId id="286" r:id="rId37"/>
     <p:sldId id="287" r:id="rId38"/>
     <p:sldId id="288" r:id="rId39"/>
+    <p:sldId id="289" r:id="rId40"/>
+    <p:sldId id="290" r:id="rId41"/>
+    <p:sldId id="291" r:id="rId42"/>
+    <p:sldId id="292" r:id="rId43"/>
+    <p:sldId id="293" r:id="rId44"/>
+    <p:sldId id="294" r:id="rId45"/>
   </p:sldIdLst>
   <p:sldSz cx="12191695" cy="6858000" type="screen4x3"/>
   <p:notesSz cx="6858000" cy="9144000"/>
@@ -6344,7 +6350,7 @@
               </a:defRPr>
             </a:pPr>
             <a:r>
-              <a:t>8.  真實案例深度拆解</a:t>
+              <a:t>8.  如何購買EM菌與光合菌</a:t>
             </a:r>
           </a:p>
           <a:p>
@@ -6359,7 +6365,7 @@
               </a:defRPr>
             </a:pPr>
             <a:r>
-              <a:t>9.  常見失敗與排除</a:t>
+              <a:t>9.  食工所免費課程資訊</a:t>
             </a:r>
           </a:p>
           <a:p>
@@ -6374,7 +6380,7 @@
               </a:defRPr>
             </a:pPr>
             <a:r>
-              <a:t>10. 風險與注意事項</a:t>
+              <a:t>10. 真實案例深度拆解</a:t>
             </a:r>
           </a:p>
           <a:p>
@@ -6389,7 +6395,37 @@
               </a:defRPr>
             </a:pPr>
             <a:r>
-              <a:t>11. 總結效益矩陣</a:t>
+              <a:t>11. 常見失敗與排除</a:t>
+            </a:r>
+          </a:p>
+          <a:p>
+            <a:pPr>
+              <a:spcAft>
+                <a:spcPts val="1000"/>
+              </a:spcAft>
+              <a:defRPr sz="2000" b="1">
+                <a:solidFill>
+                  <a:srgbClr val="2D6A4F"/>
+                </a:solidFill>
+              </a:defRPr>
+            </a:pPr>
+            <a:r>
+              <a:t>12. 風險與注意事項</a:t>
+            </a:r>
+          </a:p>
+          <a:p>
+            <a:pPr>
+              <a:spcAft>
+                <a:spcPts val="1000"/>
+              </a:spcAft>
+              <a:defRPr sz="2000" b="1">
+                <a:solidFill>
+                  <a:srgbClr val="2D6A4F"/>
+                </a:solidFill>
+              </a:defRPr>
+            </a:pPr>
+            <a:r>
+              <a:t>13. 總結效益矩陣</a:t>
             </a:r>
           </a:p>
         </p:txBody>
@@ -8150,7 +8186,7 @@
               </a:defRPr>
             </a:pPr>
             <a:r>
-              <a:t>真實案例深度拆解</a:t>
+              <a:t>如何購買EM菌與光合菌</a:t>
             </a:r>
           </a:p>
           <a:p>
@@ -8162,7 +8198,7 @@
               </a:defRPr>
             </a:pPr>
             <a:r>
-              <a:t>台灣農民第一手實證數據</a:t>
+              <a:t>實體通路 · 線上通路 · 價格參考 · 注意陷阱</a:t>
             </a:r>
           </a:p>
         </p:txBody>
@@ -8266,7 +8302,7 @@
               </a:defRPr>
             </a:pPr>
             <a:r>
-              <a:t>案例一：台南善化紅龍果——黃政德</a:t>
+              <a:t>如何購買 EM 菌</a:t>
             </a:r>
           </a:p>
         </p:txBody>
@@ -8304,7 +8340,7 @@
                   <a:srgbClr val="2D6A4F"/>
                 </a:solidFill>
               </a:rPr>
-              <a:t>背景
+              <a:t>線上購買管道
 </a:t>
             </a:r>
             <a:r>
@@ -8313,9 +8349,10 @@
                   <a:srgbClr val="1B4332"/>
                 </a:solidFill>
               </a:rPr>
-              <a:t>4分地紅龍果園，2016年導入光合菌
-原慣行農法全面轉型
-試驗兩行對照：光合菌無肥 vs 慣行施肥</a:t>
+              <a:t>蝦皮購物：搜尋「EM菌」、「EM菌種」，價格 140~450 元/L
+露天拍賣：搜尋「EM益生菌」，價格 150~500 元/L
+PChome / momo：搜尋「EM Environment」，價格 200~600 元/L
+BigGo：比價所有平台，查即時價格</a:t>
             </a:r>
           </a:p>
           <a:p>
@@ -8330,7 +8367,7 @@
                   <a:srgbClr val="2D6A4F"/>
                 </a:solidFill>
               </a:rPr>
-              <a:t>成效數據
+              <a:t>實體管道
 </a:t>
             </a:r>
             <a:r>
@@ -8339,11 +8376,10 @@
                   <a:srgbClr val="1B4332"/>
                 </a:solidFill>
               </a:rPr>
-              <a:t>實驗組單果重：2公斤（對照組0.8~1.2kg）
-產期延長至冬季仍可產出
-肥料用量降至原有的 1/5
-年肥料費：60,000元 → 12,000元
-材料成本：第一年25,000元 → 第三年後3,000元/年</a:t>
+              <a:t>各地農會供銷部
+農業資材行（鄉鎮級）
+水族館（水族用EM菌，濃度較低）
+農藥行有機資材專區</a:t>
             </a:r>
           </a:p>
           <a:p>
@@ -8358,7 +8394,7 @@
                   <a:srgbClr val="2D6A4F"/>
                 </a:solidFill>
               </a:rPr>
-              <a:t>教訓
+              <a:t>價格參考
 </a:t>
             </a:r>
             <a:r>
@@ -8367,9 +8403,62 @@
                   <a:srgbClr val="1B4332"/>
                 </a:solidFill>
               </a:rPr>
-              <a:t>根莖類作物膨大期禁止使用
-開花前最佳使用時機
-長期需搭配基礎施肥</a:t>
+              <a:t>1L瓶裝：150~300元／5L桶裝：400~800元
+20L桶裝：1,200~3,000元
+EM菌種粉500g（自產劑）：150~250元 → 可產40L
+買自產劑自製僅市售1/10價格</a:t>
+            </a:r>
+          </a:p>
+          <a:p>
+            <a:pPr>
+              <a:spcAft>
+                <a:spcPts val="800"/>
+              </a:spcAft>
+            </a:pPr>
+            <a:r>
+              <a:rPr sz="1600" b="1">
+                <a:solidFill>
+                  <a:srgbClr val="2D6A4F"/>
+                </a:solidFill>
+              </a:rPr>
+              <a:t>⚠ 保存期限
+</a:t>
+            </a:r>
+            <a:r>
+              <a:rPr sz="1600">
+                <a:solidFill>
+                  <a:srgbClr val="1B4332"/>
+                </a:solidFill>
+              </a:rPr>
+              <a:t>液體EM菌出廠超過2個月活菌數大幅下降
+購買時務必確認製造日期
+自製菌液1個月內最佳，2個月後活菌降約50%</a:t>
+            </a:r>
+          </a:p>
+          <a:p>
+            <a:pPr>
+              <a:spcAft>
+                <a:spcPts val="800"/>
+              </a:spcAft>
+            </a:pPr>
+            <a:r>
+              <a:rPr sz="1600" b="1">
+                <a:solidFill>
+                  <a:srgbClr val="2D6A4F"/>
+                </a:solidFill>
+              </a:rPr>
+              <a:t>💡 省錢結論
+</a:t>
+            </a:r>
+            <a:r>
+              <a:rPr sz="1600">
+                <a:solidFill>
+                  <a:srgbClr val="1B4332"/>
+                </a:solidFill>
+              </a:rPr>
+              <a:t>買EM活菌自產劑500g（150~250元）回來自製
+首次桶子+自產劑總花費不到500元
+之後每次培養僅花糖錢約100元</a:t>
             </a:r>
           </a:p>
         </p:txBody>
@@ -8473,7 +8562,7 @@
               </a:defRPr>
             </a:pPr>
             <a:r>
-              <a:t>案例二：屏東芒果——林毓健</a:t>
+              <a:t>如何購買光合菌</a:t>
             </a:r>
           </a:p>
         </p:txBody>
@@ -8511,7 +8600,7 @@
                   <a:srgbClr val="2D6A4F"/>
                 </a:solidFill>
               </a:rPr>
-              <a:t>背景
+              <a:t>線上購買管道
 </a:t>
             </a:r>
             <a:r>
@@ -8520,9 +8609,10 @@
                   <a:srgbClr val="1B4332"/>
                 </a:solidFill>
               </a:rPr>
-              <a:t>2018年參加食工所光合菌課程
-以往市售光合菌 20L = 2,500元
-自製成本不到 200元/20L</a:t>
+              <a:t>蝦皮搜尋「光合菌」：20L桶裝 / 1L瓶裝，150~500元
+仲達生物科技：自行培養組合，500~1,000元
+蕭博士光合菌：培養基90元/包（可產15L）
+水產試驗所：直接電話洽詢，技術轉移</a:t>
             </a:r>
           </a:p>
           <a:p>
@@ -8537,7 +8627,7 @@
                   <a:srgbClr val="2D6A4F"/>
                 </a:solidFill>
               </a:rPr>
-              <a:t>操作
+              <a:t>如何判斷好壞
 </a:t>
             </a:r>
             <a:r>
@@ -8546,9 +8636,9 @@
                   <a:srgbClr val="1B4332"/>
                 </a:solidFill>
               </a:rPr>
-              <a:t>稀釋300~500倍，每月2次灌根
-避開開花期（否則長葉不開花）
-不混用殺菌劑</a:t>
+              <a:t>✅ 好菌：暗紅/紫紅色 · 醬油香或烏梅味 · 食工所來源
+❌ 壞菌：灰黑/綠色混濁 · 惡臭酸敗 · 來路不明
+⚠ 台大研究：市售部分產品完全不含光合菌</a:t>
             </a:r>
           </a:p>
           <a:p>
@@ -8563,7 +8653,7 @@
                   <a:srgbClr val="2D6A4F"/>
                 </a:solidFill>
               </a:rPr>
-              <a:t>成效
+              <a:t>最佳取得管道
 </a:t>
             </a:r>
             <a:r>
@@ -8572,9 +8662,9 @@
                   <a:srgbClr val="1B4332"/>
                 </a:solidFill>
               </a:rPr>
-              <a:t>芒果樹勢健康、葉片旺盛
-連續使用3年效果累積
-「市售光合菌很混亂，不敢亂買」</a:t>
+              <a:t>食品工業發展研究所（FIRDI）→ 參加免費光合菌課程
+課堂上提供母菌+培養基配方 → 自己回去擴培
+這是成本最低、品質最可靠的方式</a:t>
             </a:r>
           </a:p>
         </p:txBody>
@@ -8588,6 +8678,157 @@
 </file>
 
 <file path=ppt/slides/slide27.xml><?xml version="1.0" encoding="utf-8"?>
+<p:sld xmlns:a="http://schemas.openxmlformats.org/drawingml/2006/main" xmlns:p="http://schemas.openxmlformats.org/presentationml/2006/main" xmlns:r="http://schemas.openxmlformats.org/officeDocument/2006/relationships">
+  <p:cSld>
+    <p:bg>
+      <p:bgPr>
+        <a:solidFill>
+          <a:srgbClr val="2D6A4F"/>
+        </a:solidFill>
+        <a:effectLst/>
+      </p:bgPr>
+    </p:bg>
+    <p:spTree>
+      <p:nvGrpSpPr>
+        <p:cNvPr id="1" name=""/>
+        <p:cNvGrpSpPr/>
+        <p:nvPr/>
+      </p:nvGrpSpPr>
+      <p:grpSpPr/>
+      <p:sp>
+        <p:nvSpPr>
+          <p:cNvPr id="2" name="Rectangle 1"/>
+          <p:cNvSpPr/>
+          <p:nvPr/>
+        </p:nvSpPr>
+        <p:spPr>
+          <a:xfrm>
+            <a:off x="0" y="3200400"/>
+            <a:ext cx="12191695" cy="36576"/>
+          </a:xfrm>
+          <a:prstGeom prst="rect">
+            <a:avLst/>
+          </a:prstGeom>
+          <a:solidFill>
+            <a:srgbClr val="95D5B2"/>
+          </a:solidFill>
+          <a:ln>
+            <a:noFill/>
+          </a:ln>
+        </p:spPr>
+        <p:style>
+          <a:lnRef idx="1">
+            <a:schemeClr val="accent1"/>
+          </a:lnRef>
+          <a:fillRef idx="3">
+            <a:schemeClr val="accent1"/>
+          </a:fillRef>
+          <a:effectRef idx="2">
+            <a:schemeClr val="accent1"/>
+          </a:effectRef>
+          <a:fontRef idx="minor">
+            <a:schemeClr val="lt1"/>
+          </a:fontRef>
+        </p:style>
+        <p:txBody>
+          <a:bodyPr rtlCol="0" anchor="ctr"/>
+          <a:lstStyle/>
+          <a:p>
+            <a:pPr algn="ctr"/>
+          </a:p>
+        </p:txBody>
+      </p:sp>
+      <p:sp>
+        <p:nvSpPr>
+          <p:cNvPr id="3" name="TextBox 2"/>
+          <p:cNvSpPr txBox="1"/>
+          <p:nvPr/>
+        </p:nvSpPr>
+        <p:spPr>
+          <a:xfrm>
+            <a:off x="914400" y="1645920"/>
+            <a:ext cx="10332720" cy="914400"/>
+          </a:xfrm>
+          <a:prstGeom prst="rect">
+            <a:avLst/>
+          </a:prstGeom>
+          <a:noFill/>
+        </p:spPr>
+        <p:txBody>
+          <a:bodyPr wrap="none">
+            <a:spAutoFit/>
+          </a:bodyPr>
+          <a:lstStyle/>
+          <a:p>
+            <a:pPr algn="ctr">
+              <a:defRPr sz="2000">
+                <a:solidFill>
+                  <a:srgbClr val="95D5B2"/>
+                </a:solidFill>
+              </a:defRPr>
+            </a:pPr>
+            <a:r>
+              <a:t>第玖部分</a:t>
+            </a:r>
+          </a:p>
+        </p:txBody>
+      </p:sp>
+      <p:sp>
+        <p:nvSpPr>
+          <p:cNvPr id="4" name="TextBox 3"/>
+          <p:cNvSpPr txBox="1"/>
+          <p:nvPr/>
+        </p:nvSpPr>
+        <p:spPr>
+          <a:xfrm>
+            <a:off x="914400" y="2377440"/>
+            <a:ext cx="10332720" cy="1097280"/>
+          </a:xfrm>
+          <a:prstGeom prst="rect">
+            <a:avLst/>
+          </a:prstGeom>
+          <a:noFill/>
+        </p:spPr>
+        <p:txBody>
+          <a:bodyPr wrap="none">
+            <a:spAutoFit/>
+          </a:bodyPr>
+          <a:lstStyle/>
+          <a:p>
+            <a:pPr algn="ctr">
+              <a:defRPr sz="4000" b="1">
+                <a:solidFill>
+                  <a:srgbClr val="FFFFFF"/>
+                </a:solidFill>
+              </a:defRPr>
+            </a:pPr>
+            <a:r>
+              <a:t>食工所免費光合菌課程</a:t>
+            </a:r>
+          </a:p>
+          <a:p>
+            <a:pPr algn="ctr">
+              <a:defRPr sz="1800">
+                <a:solidFill>
+                  <a:srgbClr val="B7E4C7"/>
+                </a:solidFill>
+              </a:defRPr>
+            </a:pPr>
+            <a:r>
+              <a:t>農業部農糧署全額補助</a:t>
+            </a:r>
+          </a:p>
+        </p:txBody>
+      </p:sp>
+    </p:spTree>
+  </p:cSld>
+  <p:clrMapOvr>
+    <a:masterClrMapping/>
+  </p:clrMapOvr>
+</p:sld>
+</file>
+
+<file path=ppt/slides/slide28.xml><?xml version="1.0" encoding="utf-8"?>
 <p:sld xmlns:a="http://schemas.openxmlformats.org/drawingml/2006/main" xmlns:p="http://schemas.openxmlformats.org/presentationml/2006/main" xmlns:r="http://schemas.openxmlformats.org/officeDocument/2006/relationships">
   <p:cSld>
     <p:bg>
@@ -8678,7 +8919,7 @@
               </a:defRPr>
             </a:pPr>
             <a:r>
-              <a:t>案例三：中國EM菌養豬場 + 案例四：屏東縣政府</a:t>
+              <a:t>食工所課程資訊</a:t>
             </a:r>
           </a:p>
         </p:txBody>
@@ -8716,7 +8957,7 @@
                   <a:srgbClr val="2D6A4F"/>
                 </a:solidFill>
               </a:rPr>
-              <a:t>EM菌養豬場實證數據
+              <a:t>基本資訊
 </a:t>
             </a:r>
             <a:r>
@@ -8725,12 +8966,13 @@
                   <a:srgbClr val="1B4332"/>
                 </a:solidFill>
               </a:rPr>
-              <a:t>料肉比 ↓ 15%
-畜舍氨氣濃度 ↓ 60~80%
-死亡率 ↓ 30~50%
-獸藥費用 ↓ 40~60%
-水產：每畝每周潑灑1kg菌液
-飼料添加：100~200ml + 糖200g + 水15kg</a:t>
+              <a:t>主辦：食品工業發展研究所（FIRDI）
+補助：農業部農糧署
+名稱：農業光合菌訓練班
+費用：免費（農糧署全額補助）
+對象：農民、青農、有興趣者
+內容：光合菌簡介、培養技術、田間應用、實作
+現場提供：母菌+培養基配方+操作教學</a:t>
             </a:r>
           </a:p>
           <a:p>
@@ -8745,7 +8987,7 @@
                   <a:srgbClr val="2D6A4F"/>
                 </a:solidFill>
               </a:rPr>
-              <a:t>屏東縣政府推廣光合菌
+              <a:t>追蹤最新課程方式
 </a:t>
             </a:r>
             <a:r>
@@ -8754,11 +8996,38 @@
                   <a:srgbClr val="1B4332"/>
                 </a:solidFill>
               </a:rPr>
-              <a:t>縣府農業處邀請食工所廖麗玲博士指導
-光合菌具固氮溶磷作用
-增加土壤益菌量
-提高作物吸收力與品質
-達農藥及肥料減量目標</a:t>
+              <a:t>食工所FB：搜尋「財團法人食品工業發展研究所」或 @firdi1965
+食工所官網：www.firdi.org.tw → 產業學院
+各地農會公告：台南新市農會、雲林豐泰文教基金會等協辦
+有機農業全球資訊網：info.organic.org.tw
+上下游新聞：www.newsmarket.com.tw</a:t>
+            </a:r>
+          </a:p>
+          <a:p>
+            <a:pPr>
+              <a:spcAft>
+                <a:spcPts val="800"/>
+              </a:spcAft>
+            </a:pPr>
+            <a:r>
+              <a:rPr sz="1600" b="1">
+                <a:solidFill>
+                  <a:srgbClr val="2D6A4F"/>
+                </a:solidFill>
+              </a:rPr>
+              <a:t>114年度實際開課紀錄
+</a:t>
+            </a:r>
+            <a:r>
+              <a:rPr sz="1600">
+                <a:solidFill>
+                  <a:srgbClr val="1B4332"/>
+                </a:solidFill>
+              </a:rPr>
+              <a:t>2025年3月：宜蘭場（花改場蘭陽分場）
+2025年5月：台南新市農會
+2025年6月：雲林場（豐泰文教基金會）
+每年約3~7月開課，建議現在追蹤食工所FB</a:t>
             </a:r>
           </a:p>
         </p:txBody>
@@ -8771,7 +9040,261 @@
 </p:sld>
 </file>
 
-<file path=ppt/slides/slide28.xml><?xml version="1.0" encoding="utf-8"?>
+<file path=ppt/slides/slide29.xml><?xml version="1.0" encoding="utf-8"?>
+<p:sld xmlns:a="http://schemas.openxmlformats.org/drawingml/2006/main" xmlns:p="http://schemas.openxmlformats.org/presentationml/2006/main" xmlns:r="http://schemas.openxmlformats.org/officeDocument/2006/relationships">
+  <p:cSld>
+    <p:bg>
+      <p:bgPr>
+        <a:solidFill>
+          <a:srgbClr val="F0F7F4"/>
+        </a:solidFill>
+        <a:effectLst/>
+      </p:bgPr>
+    </p:bg>
+    <p:spTree>
+      <p:nvGrpSpPr>
+        <p:cNvPr id="1" name=""/>
+        <p:cNvGrpSpPr/>
+        <p:nvPr/>
+      </p:nvGrpSpPr>
+      <p:grpSpPr/>
+      <p:sp>
+        <p:nvSpPr>
+          <p:cNvPr id="2" name="Rectangle 1"/>
+          <p:cNvSpPr/>
+          <p:nvPr/>
+        </p:nvSpPr>
+        <p:spPr>
+          <a:xfrm>
+            <a:off x="0" y="0"/>
+            <a:ext cx="12191695" cy="822960"/>
+          </a:xfrm>
+          <a:prstGeom prst="rect">
+            <a:avLst/>
+          </a:prstGeom>
+          <a:solidFill>
+            <a:srgbClr val="2D6A4F"/>
+          </a:solidFill>
+          <a:ln>
+            <a:noFill/>
+          </a:ln>
+        </p:spPr>
+        <p:style>
+          <a:lnRef idx="1">
+            <a:schemeClr val="accent1"/>
+          </a:lnRef>
+          <a:fillRef idx="3">
+            <a:schemeClr val="accent1"/>
+          </a:fillRef>
+          <a:effectRef idx="2">
+            <a:schemeClr val="accent1"/>
+          </a:effectRef>
+          <a:fontRef idx="minor">
+            <a:schemeClr val="lt1"/>
+          </a:fontRef>
+        </p:style>
+        <p:txBody>
+          <a:bodyPr rtlCol="0" anchor="ctr"/>
+          <a:lstStyle/>
+          <a:p>
+            <a:pPr algn="ctr"/>
+          </a:p>
+        </p:txBody>
+      </p:sp>
+      <p:sp>
+        <p:nvSpPr>
+          <p:cNvPr id="3" name="TextBox 2"/>
+          <p:cNvSpPr txBox="1"/>
+          <p:nvPr/>
+        </p:nvSpPr>
+        <p:spPr>
+          <a:xfrm>
+            <a:off x="457200" y="109728"/>
+            <a:ext cx="11247120" cy="640080"/>
+          </a:xfrm>
+          <a:prstGeom prst="rect">
+            <a:avLst/>
+          </a:prstGeom>
+          <a:noFill/>
+        </p:spPr>
+        <p:txBody>
+          <a:bodyPr wrap="none">
+            <a:spAutoFit/>
+          </a:bodyPr>
+          <a:lstStyle/>
+          <a:p>
+            <a:pPr>
+              <a:defRPr sz="2800" b="1">
+                <a:solidFill>
+                  <a:srgbClr val="FFFFFF"/>
+                </a:solidFill>
+              </a:defRPr>
+            </a:pPr>
+            <a:r>
+              <a:t>母菌取得替代方案</a:t>
+            </a:r>
+          </a:p>
+        </p:txBody>
+      </p:sp>
+      <p:sp>
+        <p:nvSpPr>
+          <p:cNvPr id="4" name="TextBox 3"/>
+          <p:cNvSpPr txBox="1"/>
+          <p:nvPr/>
+        </p:nvSpPr>
+        <p:spPr>
+          <a:xfrm>
+            <a:off x="457200" y="1097280"/>
+            <a:ext cx="11247120" cy="5029200"/>
+          </a:xfrm>
+          <a:prstGeom prst="rect">
+            <a:avLst/>
+          </a:prstGeom>
+          <a:noFill/>
+        </p:spPr>
+        <p:txBody>
+          <a:bodyPr wrap="square">
+            <a:spAutoFit/>
+          </a:bodyPr>
+          <a:lstStyle/>
+          <a:p>
+            <a:pPr>
+              <a:spcAft>
+                <a:spcPts val="800"/>
+              </a:spcAft>
+            </a:pPr>
+            <a:r>
+              <a:rPr sz="1600" b="1">
+                <a:solidFill>
+                  <a:srgbClr val="2D6A4F"/>
+                </a:solidFill>
+              </a:rPr>
+              <a:t>方案一：食工所 BCRC
+</a:t>
+            </a:r>
+            <a:r>
+              <a:rPr sz="1600">
+                <a:solidFill>
+                  <a:srgbClr val="1B4332"/>
+                </a:solidFill>
+              </a:rPr>
+              <a:t>電話：(03)522-3191
+直接詢問是否可購買光合菌菌種
+生物資源保存中心有保存多種菌株</a:t>
+            </a:r>
+          </a:p>
+          <a:p>
+            <a:pPr>
+              <a:spcAft>
+                <a:spcPts val="800"/>
+              </a:spcAft>
+            </a:pPr>
+            <a:r>
+              <a:rPr sz="1600" b="1">
+                <a:solidFill>
+                  <a:srgbClr val="2D6A4F"/>
+                </a:solidFill>
+              </a:rPr>
+              <a:t>方案二：水產試驗所
+</a:t>
+            </a:r>
+            <a:r>
+              <a:rPr sz="1600">
+                <a:solidFill>
+                  <a:srgbClr val="1B4332"/>
+                </a:solidFill>
+              </a:rPr>
+              <a:t>海水養殖研究中心 (06)788-0461
+洽詢是否有開放菌種購買或技術轉移</a:t>
+            </a:r>
+          </a:p>
+          <a:p>
+            <a:pPr>
+              <a:spcAft>
+                <a:spcPts val="800"/>
+              </a:spcAft>
+            </a:pPr>
+            <a:r>
+              <a:rPr sz="1600" b="1">
+                <a:solidFill>
+                  <a:srgbClr val="2D6A4F"/>
+                </a:solidFill>
+              </a:rPr>
+              <a:t>方案三：問附近產銷班
+</a:t>
+            </a:r>
+            <a:r>
+              <a:rPr sz="1600">
+                <a:solidFill>
+                  <a:srgbClr val="1B4332"/>
+                </a:solidFill>
+              </a:rPr>
+              <a:t>詢問已上過食工所課程的農友
+可向他們索取少量母菌開始培養</a:t>
+            </a:r>
+          </a:p>
+          <a:p>
+            <a:pPr>
+              <a:spcAft>
+                <a:spcPts val="800"/>
+              </a:spcAft>
+            </a:pPr>
+            <a:r>
+              <a:rPr sz="1600" b="1">
+                <a:solidFill>
+                  <a:srgbClr val="2D6A4F"/>
+                </a:solidFill>
+              </a:rPr>
+              <a:t>方案四：先買市售試用
+</a:t>
+            </a:r>
+            <a:r>
+              <a:rPr sz="1600">
+                <a:solidFill>
+                  <a:srgbClr val="1B4332"/>
+                </a:solidFill>
+              </a:rPr>
+              <a:t>蝦皮買一瓶150元光合菌液 → 當母菌+培養基+RO水擴培
+不是食工所純菌但成本極低，先感受效果</a:t>
+            </a:r>
+          </a:p>
+          <a:p>
+            <a:pPr>
+              <a:spcAft>
+                <a:spcPts val="800"/>
+              </a:spcAft>
+            </a:pPr>
+            <a:r>
+              <a:rPr sz="1600" b="1">
+                <a:solidFill>
+                  <a:srgbClr val="2D6A4F"/>
+                </a:solidFill>
+              </a:rPr>
+              <a:t>🍯 蜂蜜 trick
+</a:t>
+            </a:r>
+            <a:r>
+              <a:rPr sz="1600">
+                <a:solidFill>
+                  <a:srgbClr val="1B4332"/>
+                </a:solidFill>
+              </a:rPr>
+              <a:t>先去蝦皮買一瓶150元光合菌液當母菌
++ 培養基90元 + RO水 → 先擴培試用
+之後再參加食工所課程拿正版母菌</a:t>
+            </a:r>
+          </a:p>
+        </p:txBody>
+      </p:sp>
+    </p:spTree>
+  </p:cSld>
+  <p:clrMapOvr>
+    <a:masterClrMapping/>
+  </p:clrMapOvr>
+</p:sld>
+</file>
+
+<file path=ppt/slides/slide3.xml><?xml version="1.0" encoding="utf-8"?>
 <p:sld xmlns:a="http://schemas.openxmlformats.org/drawingml/2006/main" xmlns:p="http://schemas.openxmlformats.org/presentationml/2006/main" xmlns:r="http://schemas.openxmlformats.org/officeDocument/2006/relationships">
   <p:cSld>
     <p:bg>
@@ -8862,7 +9385,7 @@
               </a:defRPr>
             </a:pPr>
             <a:r>
-              <a:t>第玖部分</a:t>
+              <a:t>第壹部分</a:t>
             </a:r>
           </a:p>
         </p:txBody>
@@ -8897,7 +9420,7 @@
               </a:defRPr>
             </a:pPr>
             <a:r>
-              <a:t>常見失敗原因與排除對策</a:t>
+              <a:t>EM菌與光合菌概論</a:t>
             </a:r>
           </a:p>
         </p:txBody>
@@ -8910,7 +9433,158 @@
 </p:sld>
 </file>
 
-<file path=ppt/slides/slide29.xml><?xml version="1.0" encoding="utf-8"?>
+<file path=ppt/slides/slide30.xml><?xml version="1.0" encoding="utf-8"?>
+<p:sld xmlns:a="http://schemas.openxmlformats.org/drawingml/2006/main" xmlns:p="http://schemas.openxmlformats.org/presentationml/2006/main" xmlns:r="http://schemas.openxmlformats.org/officeDocument/2006/relationships">
+  <p:cSld>
+    <p:bg>
+      <p:bgPr>
+        <a:solidFill>
+          <a:srgbClr val="2D6A4F"/>
+        </a:solidFill>
+        <a:effectLst/>
+      </p:bgPr>
+    </p:bg>
+    <p:spTree>
+      <p:nvGrpSpPr>
+        <p:cNvPr id="1" name=""/>
+        <p:cNvGrpSpPr/>
+        <p:nvPr/>
+      </p:nvGrpSpPr>
+      <p:grpSpPr/>
+      <p:sp>
+        <p:nvSpPr>
+          <p:cNvPr id="2" name="Rectangle 1"/>
+          <p:cNvSpPr/>
+          <p:nvPr/>
+        </p:nvSpPr>
+        <p:spPr>
+          <a:xfrm>
+            <a:off x="0" y="3200400"/>
+            <a:ext cx="12191695" cy="36576"/>
+          </a:xfrm>
+          <a:prstGeom prst="rect">
+            <a:avLst/>
+          </a:prstGeom>
+          <a:solidFill>
+            <a:srgbClr val="95D5B2"/>
+          </a:solidFill>
+          <a:ln>
+            <a:noFill/>
+          </a:ln>
+        </p:spPr>
+        <p:style>
+          <a:lnRef idx="1">
+            <a:schemeClr val="accent1"/>
+          </a:lnRef>
+          <a:fillRef idx="3">
+            <a:schemeClr val="accent1"/>
+          </a:fillRef>
+          <a:effectRef idx="2">
+            <a:schemeClr val="accent1"/>
+          </a:effectRef>
+          <a:fontRef idx="minor">
+            <a:schemeClr val="lt1"/>
+          </a:fontRef>
+        </p:style>
+        <p:txBody>
+          <a:bodyPr rtlCol="0" anchor="ctr"/>
+          <a:lstStyle/>
+          <a:p>
+            <a:pPr algn="ctr"/>
+          </a:p>
+        </p:txBody>
+      </p:sp>
+      <p:sp>
+        <p:nvSpPr>
+          <p:cNvPr id="3" name="TextBox 2"/>
+          <p:cNvSpPr txBox="1"/>
+          <p:nvPr/>
+        </p:nvSpPr>
+        <p:spPr>
+          <a:xfrm>
+            <a:off x="914400" y="1645920"/>
+            <a:ext cx="10332720" cy="914400"/>
+          </a:xfrm>
+          <a:prstGeom prst="rect">
+            <a:avLst/>
+          </a:prstGeom>
+          <a:noFill/>
+        </p:spPr>
+        <p:txBody>
+          <a:bodyPr wrap="none">
+            <a:spAutoFit/>
+          </a:bodyPr>
+          <a:lstStyle/>
+          <a:p>
+            <a:pPr algn="ctr">
+              <a:defRPr sz="2000">
+                <a:solidFill>
+                  <a:srgbClr val="95D5B2"/>
+                </a:solidFill>
+              </a:defRPr>
+            </a:pPr>
+            <a:r>
+              <a:t>第拾部分</a:t>
+            </a:r>
+          </a:p>
+        </p:txBody>
+      </p:sp>
+      <p:sp>
+        <p:nvSpPr>
+          <p:cNvPr id="4" name="TextBox 3"/>
+          <p:cNvSpPr txBox="1"/>
+          <p:nvPr/>
+        </p:nvSpPr>
+        <p:spPr>
+          <a:xfrm>
+            <a:off x="914400" y="2377440"/>
+            <a:ext cx="10332720" cy="1097280"/>
+          </a:xfrm>
+          <a:prstGeom prst="rect">
+            <a:avLst/>
+          </a:prstGeom>
+          <a:noFill/>
+        </p:spPr>
+        <p:txBody>
+          <a:bodyPr wrap="none">
+            <a:spAutoFit/>
+          </a:bodyPr>
+          <a:lstStyle/>
+          <a:p>
+            <a:pPr algn="ctr">
+              <a:defRPr sz="4000" b="1">
+                <a:solidFill>
+                  <a:srgbClr val="FFFFFF"/>
+                </a:solidFill>
+              </a:defRPr>
+            </a:pPr>
+            <a:r>
+              <a:t>真實案例深度拆解</a:t>
+            </a:r>
+          </a:p>
+          <a:p>
+            <a:pPr algn="ctr">
+              <a:defRPr sz="1800">
+                <a:solidFill>
+                  <a:srgbClr val="B7E4C7"/>
+                </a:solidFill>
+              </a:defRPr>
+            </a:pPr>
+            <a:r>
+              <a:t>台灣農民第一手實證數據</a:t>
+            </a:r>
+          </a:p>
+        </p:txBody>
+      </p:sp>
+    </p:spTree>
+  </p:cSld>
+  <p:clrMapOvr>
+    <a:masterClrMapping/>
+  </p:clrMapOvr>
+</p:sld>
+</file>
+
+<file path=ppt/slides/slide31.xml><?xml version="1.0" encoding="utf-8"?>
 <p:sld xmlns:a="http://schemas.openxmlformats.org/drawingml/2006/main" xmlns:p="http://schemas.openxmlformats.org/presentationml/2006/main" xmlns:r="http://schemas.openxmlformats.org/officeDocument/2006/relationships">
   <p:cSld>
     <p:bg>
@@ -9001,606 +9675,114 @@
               </a:defRPr>
             </a:pPr>
             <a:r>
-              <a:t>培養失敗與田間應用失敗對策</a:t>
-            </a:r>
-          </a:p>
-        </p:txBody>
-      </p:sp>
-      <p:graphicFrame>
-        <p:nvGraphicFramePr>
-          <p:cNvPr id="4" name="Table 3"/>
-          <p:cNvGraphicFramePr>
-            <a:graphicFrameLocks noGrp="1"/>
-          </p:cNvGraphicFramePr>
+              <a:t>案例一：台南善化紅龍果——黃政德</a:t>
+            </a:r>
+          </a:p>
+        </p:txBody>
+      </p:sp>
+      <p:sp>
+        <p:nvSpPr>
+          <p:cNvPr id="4" name="TextBox 3"/>
+          <p:cNvSpPr txBox="1"/>
           <p:nvPr/>
-        </p:nvGraphicFramePr>
-        <p:xfrm>
-          <a:off x="457200" y="1097280"/>
-          <a:ext cx="11247120" cy="3108960"/>
-        </p:xfrm>
-        <a:graphic>
-          <a:graphicData uri="http://schemas.openxmlformats.org/drawingml/2006/table">
-            <a:tbl>
-              <a:tblPr firstRow="1" bandRow="1">
-                <a:tableStyleId>{5C22544A-7EE6-4342-B048-85BDC9FD1C3A}</a:tableStyleId>
-              </a:tblPr>
-              <a:tblGrid>
-                <a:gridCol w="3749040"/>
-                <a:gridCol w="3749040"/>
-                <a:gridCol w="3749040"/>
-              </a:tblGrid>
-              <a:tr h="388620">
-                <a:tc>
-                  <a:txBody>
-                    <a:bodyPr/>
-                    <a:lstStyle/>
-                    <a:p>
-                      <a:pPr algn="ctr">
-                        <a:defRPr sz="1400" b="1">
-                          <a:solidFill>
-                            <a:srgbClr val="FFFFFF"/>
-                          </a:solidFill>
-                        </a:defRPr>
-                      </a:pPr>
-                      <a:r>
-                        <a:t>現象</a:t>
-                      </a:r>
-                    </a:p>
-                  </a:txBody>
-                  <a:tcPr>
-                    <a:solidFill>
-                      <a:srgbClr val="2D6A4F"/>
-                    </a:solidFill>
-                  </a:tcPr>
-                </a:tc>
-                <a:tc>
-                  <a:txBody>
-                    <a:bodyPr/>
-                    <a:lstStyle/>
-                    <a:p>
-                      <a:pPr algn="ctr">
-                        <a:defRPr sz="1400" b="1">
-                          <a:solidFill>
-                            <a:srgbClr val="FFFFFF"/>
-                          </a:solidFill>
-                        </a:defRPr>
-                      </a:pPr>
-                      <a:r>
-                        <a:t>原因</a:t>
-                      </a:r>
-                    </a:p>
-                  </a:txBody>
-                  <a:tcPr>
-                    <a:solidFill>
-                      <a:srgbClr val="2D6A4F"/>
-                    </a:solidFill>
-                  </a:tcPr>
-                </a:tc>
-                <a:tc>
-                  <a:txBody>
-                    <a:bodyPr/>
-                    <a:lstStyle/>
-                    <a:p>
-                      <a:pPr algn="ctr">
-                        <a:defRPr sz="1400" b="1">
-                          <a:solidFill>
-                            <a:srgbClr val="FFFFFF"/>
-                          </a:solidFill>
-                        </a:defRPr>
-                      </a:pPr>
-                      <a:r>
-                        <a:t>解決方案</a:t>
-                      </a:r>
-                    </a:p>
-                  </a:txBody>
-                  <a:tcPr>
-                    <a:solidFill>
-                      <a:srgbClr val="2D6A4F"/>
-                    </a:solidFill>
-                  </a:tcPr>
-                </a:tc>
-              </a:tr>
-              <a:tr h="388620">
-                <a:tc>
-                  <a:txBody>
-                    <a:bodyPr/>
-                    <a:lstStyle/>
-                    <a:p>
-                      <a:pPr algn="l">
-                        <a:defRPr sz="1300">
-                          <a:solidFill>
-                            <a:srgbClr val="1B4332"/>
-                          </a:solidFill>
-                        </a:defRPr>
-                      </a:pPr>
-                      <a:r>
-                        <a:t>菌液發黑/發臭</a:t>
-                      </a:r>
-                    </a:p>
-                  </a:txBody>
-                  <a:tcPr>
-                    <a:solidFill>
-                      <a:srgbClr val="FFFFFF"/>
-                    </a:solidFill>
-                  </a:tcPr>
-                </a:tc>
-                <a:tc>
-                  <a:txBody>
-                    <a:bodyPr/>
-                    <a:lstStyle/>
-                    <a:p>
-                      <a:pPr algn="ctr">
-                        <a:defRPr sz="1300">
-                          <a:solidFill>
-                            <a:srgbClr val="1B4332"/>
-                          </a:solidFill>
-                        </a:defRPr>
-                      </a:pPr>
-                      <a:r>
-                        <a:t>雜菌污染</a:t>
-                      </a:r>
-                    </a:p>
-                  </a:txBody>
-                  <a:tcPr>
-                    <a:solidFill>
-                      <a:srgbClr val="FFFFFF"/>
-                    </a:solidFill>
-                  </a:tcPr>
-                </a:tc>
-                <a:tc>
-                  <a:txBody>
-                    <a:bodyPr/>
-                    <a:lstStyle/>
-                    <a:p>
-                      <a:pPr algn="ctr">
-                        <a:defRPr sz="1300">
-                          <a:solidFill>
-                            <a:srgbClr val="1B4332"/>
-                          </a:solidFill>
-                        </a:defRPr>
-                      </a:pPr>
-                      <a:r>
-                        <a:t>重新培養，加強消毒，使用RO水</a:t>
-                      </a:r>
-                    </a:p>
-                  </a:txBody>
-                  <a:tcPr>
-                    <a:solidFill>
-                      <a:srgbClr val="FFFFFF"/>
-                    </a:solidFill>
-                  </a:tcPr>
-                </a:tc>
-              </a:tr>
-              <a:tr h="388620">
-                <a:tc>
-                  <a:txBody>
-                    <a:bodyPr/>
-                    <a:lstStyle/>
-                    <a:p>
-                      <a:pPr algn="l">
-                        <a:defRPr sz="1300">
-                          <a:solidFill>
-                            <a:srgbClr val="1B4332"/>
-                          </a:solidFill>
-                        </a:defRPr>
-                      </a:pPr>
-                      <a:r>
-                        <a:t>菌液不變紅</a:t>
-                      </a:r>
-                    </a:p>
-                  </a:txBody>
-                  <a:tcPr>
-                    <a:solidFill>
-                      <a:srgbClr val="E8F5E9"/>
-                    </a:solidFill>
-                  </a:tcPr>
-                </a:tc>
-                <a:tc>
-                  <a:txBody>
-                    <a:bodyPr/>
-                    <a:lstStyle/>
-                    <a:p>
-                      <a:pPr algn="ctr">
-                        <a:defRPr sz="1300">
-                          <a:solidFill>
-                            <a:srgbClr val="1B4332"/>
-                          </a:solidFill>
-                        </a:defRPr>
-                      </a:pPr>
-                      <a:r>
-                        <a:t>光照不足/溫度太低</a:t>
-                      </a:r>
-                    </a:p>
-                  </a:txBody>
-                  <a:tcPr>
-                    <a:solidFill>
-                      <a:srgbClr val="E8F5E9"/>
-                    </a:solidFill>
-                  </a:tcPr>
-                </a:tc>
-                <a:tc>
-                  <a:txBody>
-                    <a:bodyPr/>
-                    <a:lstStyle/>
-                    <a:p>
-                      <a:pPr algn="ctr">
-                        <a:defRPr sz="1300">
-                          <a:solidFill>
-                            <a:srgbClr val="1B4332"/>
-                          </a:solidFill>
-                        </a:defRPr>
-                      </a:pPr>
-                      <a:r>
-                        <a:t>移至陽光充足處，保持25°C以上</a:t>
-                      </a:r>
-                    </a:p>
-                  </a:txBody>
-                  <a:tcPr>
-                    <a:solidFill>
-                      <a:srgbClr val="E8F5E9"/>
-                    </a:solidFill>
-                  </a:tcPr>
-                </a:tc>
-              </a:tr>
-              <a:tr h="388620">
-                <a:tc>
-                  <a:txBody>
-                    <a:bodyPr/>
-                    <a:lstStyle/>
-                    <a:p>
-                      <a:pPr algn="l">
-                        <a:defRPr sz="1300">
-                          <a:solidFill>
-                            <a:srgbClr val="1B4332"/>
-                          </a:solidFill>
-                        </a:defRPr>
-                      </a:pPr>
-                      <a:r>
-                        <a:t>菌液變綠</a:t>
-                      </a:r>
-                    </a:p>
-                  </a:txBody>
-                  <a:tcPr>
-                    <a:solidFill>
-                      <a:srgbClr val="FFFFFF"/>
-                    </a:solidFill>
-                  </a:tcPr>
-                </a:tc>
-                <a:tc>
-                  <a:txBody>
-                    <a:bodyPr/>
-                    <a:lstStyle/>
-                    <a:p>
-                      <a:pPr algn="ctr">
-                        <a:defRPr sz="1300">
-                          <a:solidFill>
-                            <a:srgbClr val="1B4332"/>
-                          </a:solidFill>
-                        </a:defRPr>
-                      </a:pPr>
-                      <a:r>
-                        <a:t>藻類污染</a:t>
-                      </a:r>
-                    </a:p>
-                  </a:txBody>
-                  <a:tcPr>
-                    <a:solidFill>
-                      <a:srgbClr val="FFFFFF"/>
-                    </a:solidFill>
-                  </a:tcPr>
-                </a:tc>
-                <a:tc>
-                  <a:txBody>
-                    <a:bodyPr/>
-                    <a:lstStyle/>
-                    <a:p>
-                      <a:pPr algn="ctr">
-                        <a:defRPr sz="1300">
-                          <a:solidFill>
-                            <a:srgbClr val="1B4332"/>
-                          </a:solidFill>
-                        </a:defRPr>
-                      </a:pPr>
-                      <a:r>
-                        <a:t>加強密封避光，檢討水源</a:t>
-                      </a:r>
-                    </a:p>
-                  </a:txBody>
-                  <a:tcPr>
-                    <a:solidFill>
-                      <a:srgbClr val="FFFFFF"/>
-                    </a:solidFill>
-                  </a:tcPr>
-                </a:tc>
-              </a:tr>
-              <a:tr h="388620">
-                <a:tc>
-                  <a:txBody>
-                    <a:bodyPr/>
-                    <a:lstStyle/>
-                    <a:p>
-                      <a:pPr algn="l">
-                        <a:defRPr sz="1300">
-                          <a:solidFill>
-                            <a:srgbClr val="1B4332"/>
-                          </a:solidFill>
-                        </a:defRPr>
-                      </a:pPr>
-                      <a:r>
-                        <a:t>無明顯效果</a:t>
-                      </a:r>
-                    </a:p>
-                  </a:txBody>
-                  <a:tcPr>
-                    <a:solidFill>
-                      <a:srgbClr val="E8F5E9"/>
-                    </a:solidFill>
-                  </a:tcPr>
-                </a:tc>
-                <a:tc>
-                  <a:txBody>
-                    <a:bodyPr/>
-                    <a:lstStyle/>
-                    <a:p>
-                      <a:pPr algn="ctr">
-                        <a:defRPr sz="1300">
-                          <a:solidFill>
-                            <a:srgbClr val="1B4332"/>
-                          </a:solidFill>
-                        </a:defRPr>
-                      </a:pPr>
-                      <a:r>
-                        <a:t>濃度不足/頻率太低</a:t>
-                      </a:r>
-                    </a:p>
-                  </a:txBody>
-                  <a:tcPr>
-                    <a:solidFill>
-                      <a:srgbClr val="E8F5E9"/>
-                    </a:solidFill>
-                  </a:tcPr>
-                </a:tc>
-                <a:tc>
-                  <a:txBody>
-                    <a:bodyPr/>
-                    <a:lstStyle/>
-                    <a:p>
-                      <a:pPr algn="ctr">
-                        <a:defRPr sz="1300">
-                          <a:solidFill>
-                            <a:srgbClr val="1B4332"/>
-                          </a:solidFill>
-                        </a:defRPr>
-                      </a:pPr>
-                      <a:r>
-                        <a:t>提高至200~300倍，縮短至7天/次</a:t>
-                      </a:r>
-                    </a:p>
-                  </a:txBody>
-                  <a:tcPr>
-                    <a:solidFill>
-                      <a:srgbClr val="E8F5E9"/>
-                    </a:solidFill>
-                  </a:tcPr>
-                </a:tc>
-              </a:tr>
-              <a:tr h="388620">
-                <a:tc>
-                  <a:txBody>
-                    <a:bodyPr/>
-                    <a:lstStyle/>
-                    <a:p>
-                      <a:pPr algn="l">
-                        <a:defRPr sz="1300">
-                          <a:solidFill>
-                            <a:srgbClr val="1B4332"/>
-                          </a:solidFill>
-                        </a:defRPr>
-                      </a:pPr>
-                      <a:r>
-                        <a:t>病害增加</a:t>
-                      </a:r>
-                    </a:p>
-                  </a:txBody>
-                  <a:tcPr>
-                    <a:solidFill>
-                      <a:srgbClr val="FFFFFF"/>
-                    </a:solidFill>
-                  </a:tcPr>
-                </a:tc>
-                <a:tc>
-                  <a:txBody>
-                    <a:bodyPr/>
-                    <a:lstStyle/>
-                    <a:p>
-                      <a:pPr algn="ctr">
-                        <a:defRPr sz="1300">
-                          <a:solidFill>
-                            <a:srgbClr val="1B4332"/>
-                          </a:solidFill>
-                        </a:defRPr>
-                      </a:pPr>
-                      <a:r>
-                        <a:t>混入病原菌</a:t>
-                      </a:r>
-                    </a:p>
-                  </a:txBody>
-                  <a:tcPr>
-                    <a:solidFill>
-                      <a:srgbClr val="FFFFFF"/>
-                    </a:solidFill>
-                  </a:tcPr>
-                </a:tc>
-                <a:tc>
-                  <a:txBody>
-                    <a:bodyPr/>
-                    <a:lstStyle/>
-                    <a:p>
-                      <a:pPr algn="ctr">
-                        <a:defRPr sz="1300">
-                          <a:solidFill>
-                            <a:srgbClr val="1B4332"/>
-                          </a:solidFill>
-                        </a:defRPr>
-                      </a:pPr>
-                      <a:r>
-                        <a:t>送檢菌液，加強無菌操作</a:t>
-                      </a:r>
-                    </a:p>
-                  </a:txBody>
-                  <a:tcPr>
-                    <a:solidFill>
-                      <a:srgbClr val="FFFFFF"/>
-                    </a:solidFill>
-                  </a:tcPr>
-                </a:tc>
-              </a:tr>
-              <a:tr h="388620">
-                <a:tc>
-                  <a:txBody>
-                    <a:bodyPr/>
-                    <a:lstStyle/>
-                    <a:p>
-                      <a:pPr algn="l">
-                        <a:defRPr sz="1300">
-                          <a:solidFill>
-                            <a:srgbClr val="1B4332"/>
-                          </a:solidFill>
-                        </a:defRPr>
-                      </a:pPr>
-                      <a:r>
-                        <a:t>葉片灼傷</a:t>
-                      </a:r>
-                    </a:p>
-                  </a:txBody>
-                  <a:tcPr>
-                    <a:solidFill>
-                      <a:srgbClr val="E8F5E9"/>
-                    </a:solidFill>
-                  </a:tcPr>
-                </a:tc>
-                <a:tc>
-                  <a:txBody>
-                    <a:bodyPr/>
-                    <a:lstStyle/>
-                    <a:p>
-                      <a:pPr algn="ctr">
-                        <a:defRPr sz="1300">
-                          <a:solidFill>
-                            <a:srgbClr val="1B4332"/>
-                          </a:solidFill>
-                        </a:defRPr>
-                      </a:pPr>
-                      <a:r>
-                        <a:t>稀釋&lt;100倍/中午噴</a:t>
-                      </a:r>
-                    </a:p>
-                  </a:txBody>
-                  <a:tcPr>
-                    <a:solidFill>
-                      <a:srgbClr val="E8F5E9"/>
-                    </a:solidFill>
-                  </a:tcPr>
-                </a:tc>
-                <a:tc>
-                  <a:txBody>
-                    <a:bodyPr/>
-                    <a:lstStyle/>
-                    <a:p>
-                      <a:pPr algn="ctr">
-                        <a:defRPr sz="1300">
-                          <a:solidFill>
-                            <a:srgbClr val="1B4332"/>
-                          </a:solidFill>
-                        </a:defRPr>
-                      </a:pPr>
-                      <a:r>
-                        <a:t>300倍以上，傍晚噴施</a:t>
-                      </a:r>
-                    </a:p>
-                  </a:txBody>
-                  <a:tcPr>
-                    <a:solidFill>
-                      <a:srgbClr val="E8F5E9"/>
-                    </a:solidFill>
-                  </a:tcPr>
-                </a:tc>
-              </a:tr>
-              <a:tr h="388620">
-                <a:tc>
-                  <a:txBody>
-                    <a:bodyPr/>
-                    <a:lstStyle/>
-                    <a:p>
-                      <a:pPr algn="l">
-                        <a:defRPr sz="1300">
-                          <a:solidFill>
-                            <a:srgbClr val="1B4332"/>
-                          </a:solidFill>
-                        </a:defRPr>
-                      </a:pPr>
-                      <a:r>
-                        <a:t>花果掉落</a:t>
-                      </a:r>
-                    </a:p>
-                  </a:txBody>
-                  <a:tcPr>
-                    <a:solidFill>
-                      <a:srgbClr val="FFFFFF"/>
-                    </a:solidFill>
-                  </a:tcPr>
-                </a:tc>
-                <a:tc>
-                  <a:txBody>
-                    <a:bodyPr/>
-                    <a:lstStyle/>
-                    <a:p>
-                      <a:pPr algn="ctr">
-                        <a:defRPr sz="1300">
-                          <a:solidFill>
-                            <a:srgbClr val="1B4332"/>
-                          </a:solidFill>
-                        </a:defRPr>
-                      </a:pPr>
-                      <a:r>
-                        <a:t>開花期濃度過高</a:t>
-                      </a:r>
-                    </a:p>
-                  </a:txBody>
-                  <a:tcPr>
-                    <a:solidFill>
-                      <a:srgbClr val="FFFFFF"/>
-                    </a:solidFill>
-                  </a:tcPr>
-                </a:tc>
-                <a:tc>
-                  <a:txBody>
-                    <a:bodyPr/>
-                    <a:lstStyle/>
-                    <a:p>
-                      <a:pPr algn="ctr">
-                        <a:defRPr sz="1300">
-                          <a:solidFill>
-                            <a:srgbClr val="1B4332"/>
-                          </a:solidFill>
-                        </a:defRPr>
-                      </a:pPr>
-                      <a:r>
-                        <a:t>暫停或稀釋至800倍以上</a:t>
-                      </a:r>
-                    </a:p>
-                  </a:txBody>
-                  <a:tcPr>
-                    <a:solidFill>
-                      <a:srgbClr val="FFFFFF"/>
-                    </a:solidFill>
-                  </a:tcPr>
-                </a:tc>
-              </a:tr>
-            </a:tbl>
-          </a:graphicData>
-        </a:graphic>
-      </p:graphicFrame>
+        </p:nvSpPr>
+        <p:spPr>
+          <a:xfrm>
+            <a:off x="457200" y="1097280"/>
+            <a:ext cx="11247120" cy="5029200"/>
+          </a:xfrm>
+          <a:prstGeom prst="rect">
+            <a:avLst/>
+          </a:prstGeom>
+          <a:noFill/>
+        </p:spPr>
+        <p:txBody>
+          <a:bodyPr wrap="square">
+            <a:spAutoFit/>
+          </a:bodyPr>
+          <a:lstStyle/>
+          <a:p>
+            <a:pPr>
+              <a:spcAft>
+                <a:spcPts val="800"/>
+              </a:spcAft>
+            </a:pPr>
+            <a:r>
+              <a:rPr sz="1600" b="1">
+                <a:solidFill>
+                  <a:srgbClr val="2D6A4F"/>
+                </a:solidFill>
+              </a:rPr>
+              <a:t>背景
+</a:t>
+            </a:r>
+            <a:r>
+              <a:rPr sz="1600">
+                <a:solidFill>
+                  <a:srgbClr val="1B4332"/>
+                </a:solidFill>
+              </a:rPr>
+              <a:t>4分地紅龍果園，2016年導入光合菌
+原慣行農法全面轉型
+試驗兩行對照：光合菌無肥 vs 慣行施肥</a:t>
+            </a:r>
+          </a:p>
+          <a:p>
+            <a:pPr>
+              <a:spcAft>
+                <a:spcPts val="800"/>
+              </a:spcAft>
+            </a:pPr>
+            <a:r>
+              <a:rPr sz="1600" b="1">
+                <a:solidFill>
+                  <a:srgbClr val="2D6A4F"/>
+                </a:solidFill>
+              </a:rPr>
+              <a:t>成效數據
+</a:t>
+            </a:r>
+            <a:r>
+              <a:rPr sz="1600">
+                <a:solidFill>
+                  <a:srgbClr val="1B4332"/>
+                </a:solidFill>
+              </a:rPr>
+              <a:t>實驗組單果重：2公斤（對照組0.8~1.2kg）
+產期延長至冬季仍可產出
+肥料用量降至原有的 1/5
+年肥料費：60,000元 → 12,000元
+材料成本：第一年25,000元 → 第三年後3,000元/年</a:t>
+            </a:r>
+          </a:p>
+          <a:p>
+            <a:pPr>
+              <a:spcAft>
+                <a:spcPts val="800"/>
+              </a:spcAft>
+            </a:pPr>
+            <a:r>
+              <a:rPr sz="1600" b="1">
+                <a:solidFill>
+                  <a:srgbClr val="2D6A4F"/>
+                </a:solidFill>
+              </a:rPr>
+              <a:t>教訓
+</a:t>
+            </a:r>
+            <a:r>
+              <a:rPr sz="1600">
+                <a:solidFill>
+                  <a:srgbClr val="1B4332"/>
+                </a:solidFill>
+              </a:rPr>
+              <a:t>根莖類作物膨大期禁止使用
+開花前最佳使用時機
+長期需搭配基礎施肥</a:t>
+            </a:r>
+          </a:p>
+        </p:txBody>
+      </p:sp>
     </p:spTree>
   </p:cSld>
   <p:clrMapOvr>
@@ -9609,7 +9791,396 @@
 </p:sld>
 </file>
 
-<file path=ppt/slides/slide3.xml><?xml version="1.0" encoding="utf-8"?>
+<file path=ppt/slides/slide32.xml><?xml version="1.0" encoding="utf-8"?>
+<p:sld xmlns:a="http://schemas.openxmlformats.org/drawingml/2006/main" xmlns:p="http://schemas.openxmlformats.org/presentationml/2006/main" xmlns:r="http://schemas.openxmlformats.org/officeDocument/2006/relationships">
+  <p:cSld>
+    <p:bg>
+      <p:bgPr>
+        <a:solidFill>
+          <a:srgbClr val="F0F7F4"/>
+        </a:solidFill>
+        <a:effectLst/>
+      </p:bgPr>
+    </p:bg>
+    <p:spTree>
+      <p:nvGrpSpPr>
+        <p:cNvPr id="1" name=""/>
+        <p:cNvGrpSpPr/>
+        <p:nvPr/>
+      </p:nvGrpSpPr>
+      <p:grpSpPr/>
+      <p:sp>
+        <p:nvSpPr>
+          <p:cNvPr id="2" name="Rectangle 1"/>
+          <p:cNvSpPr/>
+          <p:nvPr/>
+        </p:nvSpPr>
+        <p:spPr>
+          <a:xfrm>
+            <a:off x="0" y="0"/>
+            <a:ext cx="12191695" cy="822960"/>
+          </a:xfrm>
+          <a:prstGeom prst="rect">
+            <a:avLst/>
+          </a:prstGeom>
+          <a:solidFill>
+            <a:srgbClr val="2D6A4F"/>
+          </a:solidFill>
+          <a:ln>
+            <a:noFill/>
+          </a:ln>
+        </p:spPr>
+        <p:style>
+          <a:lnRef idx="1">
+            <a:schemeClr val="accent1"/>
+          </a:lnRef>
+          <a:fillRef idx="3">
+            <a:schemeClr val="accent1"/>
+          </a:fillRef>
+          <a:effectRef idx="2">
+            <a:schemeClr val="accent1"/>
+          </a:effectRef>
+          <a:fontRef idx="minor">
+            <a:schemeClr val="lt1"/>
+          </a:fontRef>
+        </p:style>
+        <p:txBody>
+          <a:bodyPr rtlCol="0" anchor="ctr"/>
+          <a:lstStyle/>
+          <a:p>
+            <a:pPr algn="ctr"/>
+          </a:p>
+        </p:txBody>
+      </p:sp>
+      <p:sp>
+        <p:nvSpPr>
+          <p:cNvPr id="3" name="TextBox 2"/>
+          <p:cNvSpPr txBox="1"/>
+          <p:nvPr/>
+        </p:nvSpPr>
+        <p:spPr>
+          <a:xfrm>
+            <a:off x="457200" y="109728"/>
+            <a:ext cx="11247120" cy="640080"/>
+          </a:xfrm>
+          <a:prstGeom prst="rect">
+            <a:avLst/>
+          </a:prstGeom>
+          <a:noFill/>
+        </p:spPr>
+        <p:txBody>
+          <a:bodyPr wrap="none">
+            <a:spAutoFit/>
+          </a:bodyPr>
+          <a:lstStyle/>
+          <a:p>
+            <a:pPr>
+              <a:defRPr sz="2800" b="1">
+                <a:solidFill>
+                  <a:srgbClr val="FFFFFF"/>
+                </a:solidFill>
+              </a:defRPr>
+            </a:pPr>
+            <a:r>
+              <a:t>案例二：屏東芒果——林毓健</a:t>
+            </a:r>
+          </a:p>
+        </p:txBody>
+      </p:sp>
+      <p:sp>
+        <p:nvSpPr>
+          <p:cNvPr id="4" name="TextBox 3"/>
+          <p:cNvSpPr txBox="1"/>
+          <p:nvPr/>
+        </p:nvSpPr>
+        <p:spPr>
+          <a:xfrm>
+            <a:off x="457200" y="1097280"/>
+            <a:ext cx="11247120" cy="5029200"/>
+          </a:xfrm>
+          <a:prstGeom prst="rect">
+            <a:avLst/>
+          </a:prstGeom>
+          <a:noFill/>
+        </p:spPr>
+        <p:txBody>
+          <a:bodyPr wrap="square">
+            <a:spAutoFit/>
+          </a:bodyPr>
+          <a:lstStyle/>
+          <a:p>
+            <a:pPr>
+              <a:spcAft>
+                <a:spcPts val="800"/>
+              </a:spcAft>
+            </a:pPr>
+            <a:r>
+              <a:rPr sz="1600" b="1">
+                <a:solidFill>
+                  <a:srgbClr val="2D6A4F"/>
+                </a:solidFill>
+              </a:rPr>
+              <a:t>背景
+</a:t>
+            </a:r>
+            <a:r>
+              <a:rPr sz="1600">
+                <a:solidFill>
+                  <a:srgbClr val="1B4332"/>
+                </a:solidFill>
+              </a:rPr>
+              <a:t>2018年參加食工所光合菌課程
+以往市售光合菌 20L = 2,500元
+自製成本不到 200元/20L</a:t>
+            </a:r>
+          </a:p>
+          <a:p>
+            <a:pPr>
+              <a:spcAft>
+                <a:spcPts val="800"/>
+              </a:spcAft>
+            </a:pPr>
+            <a:r>
+              <a:rPr sz="1600" b="1">
+                <a:solidFill>
+                  <a:srgbClr val="2D6A4F"/>
+                </a:solidFill>
+              </a:rPr>
+              <a:t>操作
+</a:t>
+            </a:r>
+            <a:r>
+              <a:rPr sz="1600">
+                <a:solidFill>
+                  <a:srgbClr val="1B4332"/>
+                </a:solidFill>
+              </a:rPr>
+              <a:t>稀釋300~500倍，每月2次灌根
+避開開花期（否則長葉不開花）
+不混用殺菌劑</a:t>
+            </a:r>
+          </a:p>
+          <a:p>
+            <a:pPr>
+              <a:spcAft>
+                <a:spcPts val="800"/>
+              </a:spcAft>
+            </a:pPr>
+            <a:r>
+              <a:rPr sz="1600" b="1">
+                <a:solidFill>
+                  <a:srgbClr val="2D6A4F"/>
+                </a:solidFill>
+              </a:rPr>
+              <a:t>成效
+</a:t>
+            </a:r>
+            <a:r>
+              <a:rPr sz="1600">
+                <a:solidFill>
+                  <a:srgbClr val="1B4332"/>
+                </a:solidFill>
+              </a:rPr>
+              <a:t>芒果樹勢健康、葉片旺盛
+連續使用3年效果累積
+「市售光合菌很混亂，不敢亂買」</a:t>
+            </a:r>
+          </a:p>
+        </p:txBody>
+      </p:sp>
+    </p:spTree>
+  </p:cSld>
+  <p:clrMapOvr>
+    <a:masterClrMapping/>
+  </p:clrMapOvr>
+</p:sld>
+</file>
+
+<file path=ppt/slides/slide33.xml><?xml version="1.0" encoding="utf-8"?>
+<p:sld xmlns:a="http://schemas.openxmlformats.org/drawingml/2006/main" xmlns:p="http://schemas.openxmlformats.org/presentationml/2006/main" xmlns:r="http://schemas.openxmlformats.org/officeDocument/2006/relationships">
+  <p:cSld>
+    <p:bg>
+      <p:bgPr>
+        <a:solidFill>
+          <a:srgbClr val="F0F7F4"/>
+        </a:solidFill>
+        <a:effectLst/>
+      </p:bgPr>
+    </p:bg>
+    <p:spTree>
+      <p:nvGrpSpPr>
+        <p:cNvPr id="1" name=""/>
+        <p:cNvGrpSpPr/>
+        <p:nvPr/>
+      </p:nvGrpSpPr>
+      <p:grpSpPr/>
+      <p:sp>
+        <p:nvSpPr>
+          <p:cNvPr id="2" name="Rectangle 1"/>
+          <p:cNvSpPr/>
+          <p:nvPr/>
+        </p:nvSpPr>
+        <p:spPr>
+          <a:xfrm>
+            <a:off x="0" y="0"/>
+            <a:ext cx="12191695" cy="822960"/>
+          </a:xfrm>
+          <a:prstGeom prst="rect">
+            <a:avLst/>
+          </a:prstGeom>
+          <a:solidFill>
+            <a:srgbClr val="2D6A4F"/>
+          </a:solidFill>
+          <a:ln>
+            <a:noFill/>
+          </a:ln>
+        </p:spPr>
+        <p:style>
+          <a:lnRef idx="1">
+            <a:schemeClr val="accent1"/>
+          </a:lnRef>
+          <a:fillRef idx="3">
+            <a:schemeClr val="accent1"/>
+          </a:fillRef>
+          <a:effectRef idx="2">
+            <a:schemeClr val="accent1"/>
+          </a:effectRef>
+          <a:fontRef idx="minor">
+            <a:schemeClr val="lt1"/>
+          </a:fontRef>
+        </p:style>
+        <p:txBody>
+          <a:bodyPr rtlCol="0" anchor="ctr"/>
+          <a:lstStyle/>
+          <a:p>
+            <a:pPr algn="ctr"/>
+          </a:p>
+        </p:txBody>
+      </p:sp>
+      <p:sp>
+        <p:nvSpPr>
+          <p:cNvPr id="3" name="TextBox 2"/>
+          <p:cNvSpPr txBox="1"/>
+          <p:nvPr/>
+        </p:nvSpPr>
+        <p:spPr>
+          <a:xfrm>
+            <a:off x="457200" y="109728"/>
+            <a:ext cx="11247120" cy="640080"/>
+          </a:xfrm>
+          <a:prstGeom prst="rect">
+            <a:avLst/>
+          </a:prstGeom>
+          <a:noFill/>
+        </p:spPr>
+        <p:txBody>
+          <a:bodyPr wrap="none">
+            <a:spAutoFit/>
+          </a:bodyPr>
+          <a:lstStyle/>
+          <a:p>
+            <a:pPr>
+              <a:defRPr sz="2800" b="1">
+                <a:solidFill>
+                  <a:srgbClr val="FFFFFF"/>
+                </a:solidFill>
+              </a:defRPr>
+            </a:pPr>
+            <a:r>
+              <a:t>案例三：中國EM菌養豬場 + 案例四：屏東縣政府</a:t>
+            </a:r>
+          </a:p>
+        </p:txBody>
+      </p:sp>
+      <p:sp>
+        <p:nvSpPr>
+          <p:cNvPr id="4" name="TextBox 3"/>
+          <p:cNvSpPr txBox="1"/>
+          <p:nvPr/>
+        </p:nvSpPr>
+        <p:spPr>
+          <a:xfrm>
+            <a:off x="457200" y="1097280"/>
+            <a:ext cx="11247120" cy="5029200"/>
+          </a:xfrm>
+          <a:prstGeom prst="rect">
+            <a:avLst/>
+          </a:prstGeom>
+          <a:noFill/>
+        </p:spPr>
+        <p:txBody>
+          <a:bodyPr wrap="square">
+            <a:spAutoFit/>
+          </a:bodyPr>
+          <a:lstStyle/>
+          <a:p>
+            <a:pPr>
+              <a:spcAft>
+                <a:spcPts val="800"/>
+              </a:spcAft>
+            </a:pPr>
+            <a:r>
+              <a:rPr sz="1600" b="1">
+                <a:solidFill>
+                  <a:srgbClr val="2D6A4F"/>
+                </a:solidFill>
+              </a:rPr>
+              <a:t>EM菌養豬場實證數據
+</a:t>
+            </a:r>
+            <a:r>
+              <a:rPr sz="1600">
+                <a:solidFill>
+                  <a:srgbClr val="1B4332"/>
+                </a:solidFill>
+              </a:rPr>
+              <a:t>料肉比 ↓ 15%
+畜舍氨氣濃度 ↓ 60~80%
+死亡率 ↓ 30~50%
+獸藥費用 ↓ 40~60%
+水產：每畝每周潑灑1kg菌液
+飼料添加：100~200ml + 糖200g + 水15kg</a:t>
+            </a:r>
+          </a:p>
+          <a:p>
+            <a:pPr>
+              <a:spcAft>
+                <a:spcPts val="800"/>
+              </a:spcAft>
+            </a:pPr>
+            <a:r>
+              <a:rPr sz="1600" b="1">
+                <a:solidFill>
+                  <a:srgbClr val="2D6A4F"/>
+                </a:solidFill>
+              </a:rPr>
+              <a:t>屏東縣政府推廣光合菌
+</a:t>
+            </a:r>
+            <a:r>
+              <a:rPr sz="1600">
+                <a:solidFill>
+                  <a:srgbClr val="1B4332"/>
+                </a:solidFill>
+              </a:rPr>
+              <a:t>縣府農業處邀請食工所廖麗玲博士指導
+光合菌具固氮溶磷作用
+增加土壤益菌量
+提高作物吸收力與品質
+達農藥及肥料減量目標</a:t>
+            </a:r>
+          </a:p>
+        </p:txBody>
+      </p:sp>
+    </p:spTree>
+  </p:cSld>
+  <p:clrMapOvr>
+    <a:masterClrMapping/>
+  </p:clrMapOvr>
+</p:sld>
+</file>
+
+<file path=ppt/slides/slide34.xml><?xml version="1.0" encoding="utf-8"?>
 <p:sld xmlns:a="http://schemas.openxmlformats.org/drawingml/2006/main" xmlns:p="http://schemas.openxmlformats.org/presentationml/2006/main" xmlns:r="http://schemas.openxmlformats.org/officeDocument/2006/relationships">
   <p:cSld>
     <p:bg>
@@ -9700,7 +10271,7 @@
               </a:defRPr>
             </a:pPr>
             <a:r>
-              <a:t>第壹部分</a:t>
+              <a:t>第拾壹部分</a:t>
             </a:r>
           </a:p>
         </p:txBody>
@@ -9735,7 +10306,7 @@
               </a:defRPr>
             </a:pPr>
             <a:r>
-              <a:t>EM菌與光合菌概論</a:t>
+              <a:t>常見失敗原因與排除對策</a:t>
             </a:r>
           </a:p>
         </p:txBody>
@@ -9748,7 +10319,706 @@
 </p:sld>
 </file>
 
-<file path=ppt/slides/slide30.xml><?xml version="1.0" encoding="utf-8"?>
+<file path=ppt/slides/slide35.xml><?xml version="1.0" encoding="utf-8"?>
+<p:sld xmlns:a="http://schemas.openxmlformats.org/drawingml/2006/main" xmlns:p="http://schemas.openxmlformats.org/presentationml/2006/main" xmlns:r="http://schemas.openxmlformats.org/officeDocument/2006/relationships">
+  <p:cSld>
+    <p:bg>
+      <p:bgPr>
+        <a:solidFill>
+          <a:srgbClr val="F0F7F4"/>
+        </a:solidFill>
+        <a:effectLst/>
+      </p:bgPr>
+    </p:bg>
+    <p:spTree>
+      <p:nvGrpSpPr>
+        <p:cNvPr id="1" name=""/>
+        <p:cNvGrpSpPr/>
+        <p:nvPr/>
+      </p:nvGrpSpPr>
+      <p:grpSpPr/>
+      <p:sp>
+        <p:nvSpPr>
+          <p:cNvPr id="2" name="Rectangle 1"/>
+          <p:cNvSpPr/>
+          <p:nvPr/>
+        </p:nvSpPr>
+        <p:spPr>
+          <a:xfrm>
+            <a:off x="0" y="0"/>
+            <a:ext cx="12191695" cy="822960"/>
+          </a:xfrm>
+          <a:prstGeom prst="rect">
+            <a:avLst/>
+          </a:prstGeom>
+          <a:solidFill>
+            <a:srgbClr val="2D6A4F"/>
+          </a:solidFill>
+          <a:ln>
+            <a:noFill/>
+          </a:ln>
+        </p:spPr>
+        <p:style>
+          <a:lnRef idx="1">
+            <a:schemeClr val="accent1"/>
+          </a:lnRef>
+          <a:fillRef idx="3">
+            <a:schemeClr val="accent1"/>
+          </a:fillRef>
+          <a:effectRef idx="2">
+            <a:schemeClr val="accent1"/>
+          </a:effectRef>
+          <a:fontRef idx="minor">
+            <a:schemeClr val="lt1"/>
+          </a:fontRef>
+        </p:style>
+        <p:txBody>
+          <a:bodyPr rtlCol="0" anchor="ctr"/>
+          <a:lstStyle/>
+          <a:p>
+            <a:pPr algn="ctr"/>
+          </a:p>
+        </p:txBody>
+      </p:sp>
+      <p:sp>
+        <p:nvSpPr>
+          <p:cNvPr id="3" name="TextBox 2"/>
+          <p:cNvSpPr txBox="1"/>
+          <p:nvPr/>
+        </p:nvSpPr>
+        <p:spPr>
+          <a:xfrm>
+            <a:off x="457200" y="109728"/>
+            <a:ext cx="11247120" cy="640080"/>
+          </a:xfrm>
+          <a:prstGeom prst="rect">
+            <a:avLst/>
+          </a:prstGeom>
+          <a:noFill/>
+        </p:spPr>
+        <p:txBody>
+          <a:bodyPr wrap="none">
+            <a:spAutoFit/>
+          </a:bodyPr>
+          <a:lstStyle/>
+          <a:p>
+            <a:pPr>
+              <a:defRPr sz="2800" b="1">
+                <a:solidFill>
+                  <a:srgbClr val="FFFFFF"/>
+                </a:solidFill>
+              </a:defRPr>
+            </a:pPr>
+            <a:r>
+              <a:t>培養失敗與田間應用失敗對策</a:t>
+            </a:r>
+          </a:p>
+        </p:txBody>
+      </p:sp>
+      <p:graphicFrame>
+        <p:nvGraphicFramePr>
+          <p:cNvPr id="4" name="Table 3"/>
+          <p:cNvGraphicFramePr>
+            <a:graphicFrameLocks noGrp="1"/>
+          </p:cNvGraphicFramePr>
+          <p:nvPr/>
+        </p:nvGraphicFramePr>
+        <p:xfrm>
+          <a:off x="457200" y="1097280"/>
+          <a:ext cx="11247120" cy="3108960"/>
+        </p:xfrm>
+        <a:graphic>
+          <a:graphicData uri="http://schemas.openxmlformats.org/drawingml/2006/table">
+            <a:tbl>
+              <a:tblPr firstRow="1" bandRow="1">
+                <a:tableStyleId>{5C22544A-7EE6-4342-B048-85BDC9FD1C3A}</a:tableStyleId>
+              </a:tblPr>
+              <a:tblGrid>
+                <a:gridCol w="3749040"/>
+                <a:gridCol w="3749040"/>
+                <a:gridCol w="3749040"/>
+              </a:tblGrid>
+              <a:tr h="388620">
+                <a:tc>
+                  <a:txBody>
+                    <a:bodyPr/>
+                    <a:lstStyle/>
+                    <a:p>
+                      <a:pPr algn="ctr">
+                        <a:defRPr sz="1400" b="1">
+                          <a:solidFill>
+                            <a:srgbClr val="FFFFFF"/>
+                          </a:solidFill>
+                        </a:defRPr>
+                      </a:pPr>
+                      <a:r>
+                        <a:t>現象</a:t>
+                      </a:r>
+                    </a:p>
+                  </a:txBody>
+                  <a:tcPr>
+                    <a:solidFill>
+                      <a:srgbClr val="2D6A4F"/>
+                    </a:solidFill>
+                  </a:tcPr>
+                </a:tc>
+                <a:tc>
+                  <a:txBody>
+                    <a:bodyPr/>
+                    <a:lstStyle/>
+                    <a:p>
+                      <a:pPr algn="ctr">
+                        <a:defRPr sz="1400" b="1">
+                          <a:solidFill>
+                            <a:srgbClr val="FFFFFF"/>
+                          </a:solidFill>
+                        </a:defRPr>
+                      </a:pPr>
+                      <a:r>
+                        <a:t>原因</a:t>
+                      </a:r>
+                    </a:p>
+                  </a:txBody>
+                  <a:tcPr>
+                    <a:solidFill>
+                      <a:srgbClr val="2D6A4F"/>
+                    </a:solidFill>
+                  </a:tcPr>
+                </a:tc>
+                <a:tc>
+                  <a:txBody>
+                    <a:bodyPr/>
+                    <a:lstStyle/>
+                    <a:p>
+                      <a:pPr algn="ctr">
+                        <a:defRPr sz="1400" b="1">
+                          <a:solidFill>
+                            <a:srgbClr val="FFFFFF"/>
+                          </a:solidFill>
+                        </a:defRPr>
+                      </a:pPr>
+                      <a:r>
+                        <a:t>解決方案</a:t>
+                      </a:r>
+                    </a:p>
+                  </a:txBody>
+                  <a:tcPr>
+                    <a:solidFill>
+                      <a:srgbClr val="2D6A4F"/>
+                    </a:solidFill>
+                  </a:tcPr>
+                </a:tc>
+              </a:tr>
+              <a:tr h="388620">
+                <a:tc>
+                  <a:txBody>
+                    <a:bodyPr/>
+                    <a:lstStyle/>
+                    <a:p>
+                      <a:pPr algn="l">
+                        <a:defRPr sz="1300">
+                          <a:solidFill>
+                            <a:srgbClr val="1B4332"/>
+                          </a:solidFill>
+                        </a:defRPr>
+                      </a:pPr>
+                      <a:r>
+                        <a:t>菌液發黑/發臭</a:t>
+                      </a:r>
+                    </a:p>
+                  </a:txBody>
+                  <a:tcPr>
+                    <a:solidFill>
+                      <a:srgbClr val="FFFFFF"/>
+                    </a:solidFill>
+                  </a:tcPr>
+                </a:tc>
+                <a:tc>
+                  <a:txBody>
+                    <a:bodyPr/>
+                    <a:lstStyle/>
+                    <a:p>
+                      <a:pPr algn="ctr">
+                        <a:defRPr sz="1300">
+                          <a:solidFill>
+                            <a:srgbClr val="1B4332"/>
+                          </a:solidFill>
+                        </a:defRPr>
+                      </a:pPr>
+                      <a:r>
+                        <a:t>雜菌污染</a:t>
+                      </a:r>
+                    </a:p>
+                  </a:txBody>
+                  <a:tcPr>
+                    <a:solidFill>
+                      <a:srgbClr val="FFFFFF"/>
+                    </a:solidFill>
+                  </a:tcPr>
+                </a:tc>
+                <a:tc>
+                  <a:txBody>
+                    <a:bodyPr/>
+                    <a:lstStyle/>
+                    <a:p>
+                      <a:pPr algn="ctr">
+                        <a:defRPr sz="1300">
+                          <a:solidFill>
+                            <a:srgbClr val="1B4332"/>
+                          </a:solidFill>
+                        </a:defRPr>
+                      </a:pPr>
+                      <a:r>
+                        <a:t>重新培養，加強消毒，使用RO水</a:t>
+                      </a:r>
+                    </a:p>
+                  </a:txBody>
+                  <a:tcPr>
+                    <a:solidFill>
+                      <a:srgbClr val="FFFFFF"/>
+                    </a:solidFill>
+                  </a:tcPr>
+                </a:tc>
+              </a:tr>
+              <a:tr h="388620">
+                <a:tc>
+                  <a:txBody>
+                    <a:bodyPr/>
+                    <a:lstStyle/>
+                    <a:p>
+                      <a:pPr algn="l">
+                        <a:defRPr sz="1300">
+                          <a:solidFill>
+                            <a:srgbClr val="1B4332"/>
+                          </a:solidFill>
+                        </a:defRPr>
+                      </a:pPr>
+                      <a:r>
+                        <a:t>菌液不變紅</a:t>
+                      </a:r>
+                    </a:p>
+                  </a:txBody>
+                  <a:tcPr>
+                    <a:solidFill>
+                      <a:srgbClr val="E8F5E9"/>
+                    </a:solidFill>
+                  </a:tcPr>
+                </a:tc>
+                <a:tc>
+                  <a:txBody>
+                    <a:bodyPr/>
+                    <a:lstStyle/>
+                    <a:p>
+                      <a:pPr algn="ctr">
+                        <a:defRPr sz="1300">
+                          <a:solidFill>
+                            <a:srgbClr val="1B4332"/>
+                          </a:solidFill>
+                        </a:defRPr>
+                      </a:pPr>
+                      <a:r>
+                        <a:t>光照不足/溫度太低</a:t>
+                      </a:r>
+                    </a:p>
+                  </a:txBody>
+                  <a:tcPr>
+                    <a:solidFill>
+                      <a:srgbClr val="E8F5E9"/>
+                    </a:solidFill>
+                  </a:tcPr>
+                </a:tc>
+                <a:tc>
+                  <a:txBody>
+                    <a:bodyPr/>
+                    <a:lstStyle/>
+                    <a:p>
+                      <a:pPr algn="ctr">
+                        <a:defRPr sz="1300">
+                          <a:solidFill>
+                            <a:srgbClr val="1B4332"/>
+                          </a:solidFill>
+                        </a:defRPr>
+                      </a:pPr>
+                      <a:r>
+                        <a:t>移至陽光充足處，保持25°C以上</a:t>
+                      </a:r>
+                    </a:p>
+                  </a:txBody>
+                  <a:tcPr>
+                    <a:solidFill>
+                      <a:srgbClr val="E8F5E9"/>
+                    </a:solidFill>
+                  </a:tcPr>
+                </a:tc>
+              </a:tr>
+              <a:tr h="388620">
+                <a:tc>
+                  <a:txBody>
+                    <a:bodyPr/>
+                    <a:lstStyle/>
+                    <a:p>
+                      <a:pPr algn="l">
+                        <a:defRPr sz="1300">
+                          <a:solidFill>
+                            <a:srgbClr val="1B4332"/>
+                          </a:solidFill>
+                        </a:defRPr>
+                      </a:pPr>
+                      <a:r>
+                        <a:t>菌液變綠</a:t>
+                      </a:r>
+                    </a:p>
+                  </a:txBody>
+                  <a:tcPr>
+                    <a:solidFill>
+                      <a:srgbClr val="FFFFFF"/>
+                    </a:solidFill>
+                  </a:tcPr>
+                </a:tc>
+                <a:tc>
+                  <a:txBody>
+                    <a:bodyPr/>
+                    <a:lstStyle/>
+                    <a:p>
+                      <a:pPr algn="ctr">
+                        <a:defRPr sz="1300">
+                          <a:solidFill>
+                            <a:srgbClr val="1B4332"/>
+                          </a:solidFill>
+                        </a:defRPr>
+                      </a:pPr>
+                      <a:r>
+                        <a:t>藻類污染</a:t>
+                      </a:r>
+                    </a:p>
+                  </a:txBody>
+                  <a:tcPr>
+                    <a:solidFill>
+                      <a:srgbClr val="FFFFFF"/>
+                    </a:solidFill>
+                  </a:tcPr>
+                </a:tc>
+                <a:tc>
+                  <a:txBody>
+                    <a:bodyPr/>
+                    <a:lstStyle/>
+                    <a:p>
+                      <a:pPr algn="ctr">
+                        <a:defRPr sz="1300">
+                          <a:solidFill>
+                            <a:srgbClr val="1B4332"/>
+                          </a:solidFill>
+                        </a:defRPr>
+                      </a:pPr>
+                      <a:r>
+                        <a:t>加強密封避光，檢討水源</a:t>
+                      </a:r>
+                    </a:p>
+                  </a:txBody>
+                  <a:tcPr>
+                    <a:solidFill>
+                      <a:srgbClr val="FFFFFF"/>
+                    </a:solidFill>
+                  </a:tcPr>
+                </a:tc>
+              </a:tr>
+              <a:tr h="388620">
+                <a:tc>
+                  <a:txBody>
+                    <a:bodyPr/>
+                    <a:lstStyle/>
+                    <a:p>
+                      <a:pPr algn="l">
+                        <a:defRPr sz="1300">
+                          <a:solidFill>
+                            <a:srgbClr val="1B4332"/>
+                          </a:solidFill>
+                        </a:defRPr>
+                      </a:pPr>
+                      <a:r>
+                        <a:t>無明顯效果</a:t>
+                      </a:r>
+                    </a:p>
+                  </a:txBody>
+                  <a:tcPr>
+                    <a:solidFill>
+                      <a:srgbClr val="E8F5E9"/>
+                    </a:solidFill>
+                  </a:tcPr>
+                </a:tc>
+                <a:tc>
+                  <a:txBody>
+                    <a:bodyPr/>
+                    <a:lstStyle/>
+                    <a:p>
+                      <a:pPr algn="ctr">
+                        <a:defRPr sz="1300">
+                          <a:solidFill>
+                            <a:srgbClr val="1B4332"/>
+                          </a:solidFill>
+                        </a:defRPr>
+                      </a:pPr>
+                      <a:r>
+                        <a:t>濃度不足/頻率太低</a:t>
+                      </a:r>
+                    </a:p>
+                  </a:txBody>
+                  <a:tcPr>
+                    <a:solidFill>
+                      <a:srgbClr val="E8F5E9"/>
+                    </a:solidFill>
+                  </a:tcPr>
+                </a:tc>
+                <a:tc>
+                  <a:txBody>
+                    <a:bodyPr/>
+                    <a:lstStyle/>
+                    <a:p>
+                      <a:pPr algn="ctr">
+                        <a:defRPr sz="1300">
+                          <a:solidFill>
+                            <a:srgbClr val="1B4332"/>
+                          </a:solidFill>
+                        </a:defRPr>
+                      </a:pPr>
+                      <a:r>
+                        <a:t>提高至200~300倍，縮短至7天/次</a:t>
+                      </a:r>
+                    </a:p>
+                  </a:txBody>
+                  <a:tcPr>
+                    <a:solidFill>
+                      <a:srgbClr val="E8F5E9"/>
+                    </a:solidFill>
+                  </a:tcPr>
+                </a:tc>
+              </a:tr>
+              <a:tr h="388620">
+                <a:tc>
+                  <a:txBody>
+                    <a:bodyPr/>
+                    <a:lstStyle/>
+                    <a:p>
+                      <a:pPr algn="l">
+                        <a:defRPr sz="1300">
+                          <a:solidFill>
+                            <a:srgbClr val="1B4332"/>
+                          </a:solidFill>
+                        </a:defRPr>
+                      </a:pPr>
+                      <a:r>
+                        <a:t>病害增加</a:t>
+                      </a:r>
+                    </a:p>
+                  </a:txBody>
+                  <a:tcPr>
+                    <a:solidFill>
+                      <a:srgbClr val="FFFFFF"/>
+                    </a:solidFill>
+                  </a:tcPr>
+                </a:tc>
+                <a:tc>
+                  <a:txBody>
+                    <a:bodyPr/>
+                    <a:lstStyle/>
+                    <a:p>
+                      <a:pPr algn="ctr">
+                        <a:defRPr sz="1300">
+                          <a:solidFill>
+                            <a:srgbClr val="1B4332"/>
+                          </a:solidFill>
+                        </a:defRPr>
+                      </a:pPr>
+                      <a:r>
+                        <a:t>混入病原菌</a:t>
+                      </a:r>
+                    </a:p>
+                  </a:txBody>
+                  <a:tcPr>
+                    <a:solidFill>
+                      <a:srgbClr val="FFFFFF"/>
+                    </a:solidFill>
+                  </a:tcPr>
+                </a:tc>
+                <a:tc>
+                  <a:txBody>
+                    <a:bodyPr/>
+                    <a:lstStyle/>
+                    <a:p>
+                      <a:pPr algn="ctr">
+                        <a:defRPr sz="1300">
+                          <a:solidFill>
+                            <a:srgbClr val="1B4332"/>
+                          </a:solidFill>
+                        </a:defRPr>
+                      </a:pPr>
+                      <a:r>
+                        <a:t>送檢菌液，加強無菌操作</a:t>
+                      </a:r>
+                    </a:p>
+                  </a:txBody>
+                  <a:tcPr>
+                    <a:solidFill>
+                      <a:srgbClr val="FFFFFF"/>
+                    </a:solidFill>
+                  </a:tcPr>
+                </a:tc>
+              </a:tr>
+              <a:tr h="388620">
+                <a:tc>
+                  <a:txBody>
+                    <a:bodyPr/>
+                    <a:lstStyle/>
+                    <a:p>
+                      <a:pPr algn="l">
+                        <a:defRPr sz="1300">
+                          <a:solidFill>
+                            <a:srgbClr val="1B4332"/>
+                          </a:solidFill>
+                        </a:defRPr>
+                      </a:pPr>
+                      <a:r>
+                        <a:t>葉片灼傷</a:t>
+                      </a:r>
+                    </a:p>
+                  </a:txBody>
+                  <a:tcPr>
+                    <a:solidFill>
+                      <a:srgbClr val="E8F5E9"/>
+                    </a:solidFill>
+                  </a:tcPr>
+                </a:tc>
+                <a:tc>
+                  <a:txBody>
+                    <a:bodyPr/>
+                    <a:lstStyle/>
+                    <a:p>
+                      <a:pPr algn="ctr">
+                        <a:defRPr sz="1300">
+                          <a:solidFill>
+                            <a:srgbClr val="1B4332"/>
+                          </a:solidFill>
+                        </a:defRPr>
+                      </a:pPr>
+                      <a:r>
+                        <a:t>稀釋&lt;100倍/中午噴</a:t>
+                      </a:r>
+                    </a:p>
+                  </a:txBody>
+                  <a:tcPr>
+                    <a:solidFill>
+                      <a:srgbClr val="E8F5E9"/>
+                    </a:solidFill>
+                  </a:tcPr>
+                </a:tc>
+                <a:tc>
+                  <a:txBody>
+                    <a:bodyPr/>
+                    <a:lstStyle/>
+                    <a:p>
+                      <a:pPr algn="ctr">
+                        <a:defRPr sz="1300">
+                          <a:solidFill>
+                            <a:srgbClr val="1B4332"/>
+                          </a:solidFill>
+                        </a:defRPr>
+                      </a:pPr>
+                      <a:r>
+                        <a:t>300倍以上，傍晚噴施</a:t>
+                      </a:r>
+                    </a:p>
+                  </a:txBody>
+                  <a:tcPr>
+                    <a:solidFill>
+                      <a:srgbClr val="E8F5E9"/>
+                    </a:solidFill>
+                  </a:tcPr>
+                </a:tc>
+              </a:tr>
+              <a:tr h="388620">
+                <a:tc>
+                  <a:txBody>
+                    <a:bodyPr/>
+                    <a:lstStyle/>
+                    <a:p>
+                      <a:pPr algn="l">
+                        <a:defRPr sz="1300">
+                          <a:solidFill>
+                            <a:srgbClr val="1B4332"/>
+                          </a:solidFill>
+                        </a:defRPr>
+                      </a:pPr>
+                      <a:r>
+                        <a:t>花果掉落</a:t>
+                      </a:r>
+                    </a:p>
+                  </a:txBody>
+                  <a:tcPr>
+                    <a:solidFill>
+                      <a:srgbClr val="FFFFFF"/>
+                    </a:solidFill>
+                  </a:tcPr>
+                </a:tc>
+                <a:tc>
+                  <a:txBody>
+                    <a:bodyPr/>
+                    <a:lstStyle/>
+                    <a:p>
+                      <a:pPr algn="ctr">
+                        <a:defRPr sz="1300">
+                          <a:solidFill>
+                            <a:srgbClr val="1B4332"/>
+                          </a:solidFill>
+                        </a:defRPr>
+                      </a:pPr>
+                      <a:r>
+                        <a:t>開花期濃度過高</a:t>
+                      </a:r>
+                    </a:p>
+                  </a:txBody>
+                  <a:tcPr>
+                    <a:solidFill>
+                      <a:srgbClr val="FFFFFF"/>
+                    </a:solidFill>
+                  </a:tcPr>
+                </a:tc>
+                <a:tc>
+                  <a:txBody>
+                    <a:bodyPr/>
+                    <a:lstStyle/>
+                    <a:p>
+                      <a:pPr algn="ctr">
+                        <a:defRPr sz="1300">
+                          <a:solidFill>
+                            <a:srgbClr val="1B4332"/>
+                          </a:solidFill>
+                        </a:defRPr>
+                      </a:pPr>
+                      <a:r>
+                        <a:t>暫停或稀釋至800倍以上</a:t>
+                      </a:r>
+                    </a:p>
+                  </a:txBody>
+                  <a:tcPr>
+                    <a:solidFill>
+                      <a:srgbClr val="FFFFFF"/>
+                    </a:solidFill>
+                  </a:tcPr>
+                </a:tc>
+              </a:tr>
+            </a:tbl>
+          </a:graphicData>
+        </a:graphic>
+      </p:graphicFrame>
+    </p:spTree>
+  </p:cSld>
+  <p:clrMapOvr>
+    <a:masterClrMapping/>
+  </p:clrMapOvr>
+</p:sld>
+</file>
+
+<file path=ppt/slides/slide36.xml><?xml version="1.0" encoding="utf-8"?>
 <p:sld xmlns:a="http://schemas.openxmlformats.org/drawingml/2006/main" xmlns:p="http://schemas.openxmlformats.org/presentationml/2006/main" xmlns:r="http://schemas.openxmlformats.org/officeDocument/2006/relationships">
   <p:cSld>
     <p:bg>
@@ -9839,7 +11109,7 @@
               </a:defRPr>
             </a:pPr>
             <a:r>
-              <a:t>第拾部分</a:t>
+              <a:t>第拾貳部分</a:t>
             </a:r>
           </a:p>
         </p:txBody>
@@ -9887,7 +11157,7 @@
 </p:sld>
 </file>
 
-<file path=ppt/slides/slide31.xml><?xml version="1.0" encoding="utf-8"?>
+<file path=ppt/slides/slide37.xml><?xml version="1.0" encoding="utf-8"?>
 <p:sld xmlns:a="http://schemas.openxmlformats.org/drawingml/2006/main" xmlns:p="http://schemas.openxmlformats.org/presentationml/2006/main" xmlns:r="http://schemas.openxmlformats.org/officeDocument/2006/relationships">
   <p:cSld>
     <p:bg>
@@ -10209,7 +11479,7 @@
 </p:sld>
 </file>
 
-<file path=ppt/slides/slide32.xml><?xml version="1.0" encoding="utf-8"?>
+<file path=ppt/slides/slide38.xml><?xml version="1.0" encoding="utf-8"?>
 <p:sld xmlns:a="http://schemas.openxmlformats.org/drawingml/2006/main" xmlns:p="http://schemas.openxmlformats.org/presentationml/2006/main" xmlns:r="http://schemas.openxmlformats.org/officeDocument/2006/relationships">
   <p:cSld>
     <p:bg>
@@ -10451,7 +11721,7 @@
 </p:sld>
 </file>
 
-<file path=ppt/slides/slide33.xml><?xml version="1.0" encoding="utf-8"?>
+<file path=ppt/slides/slide39.xml><?xml version="1.0" encoding="utf-8"?>
 <p:sld xmlns:a="http://schemas.openxmlformats.org/drawingml/2006/main" xmlns:p="http://schemas.openxmlformats.org/presentationml/2006/main" xmlns:r="http://schemas.openxmlformats.org/officeDocument/2006/relationships">
   <p:cSld>
     <p:bg>

</xml_diff>